<commit_message>
added anothe slide to the presentation
</commit_message>
<xml_diff>
--- a/final_presentation.pptx
+++ b/final_presentation.pptx
@@ -13,7 +13,8 @@
     <p:sldId id="261" r:id="rId7"/>
     <p:sldId id="262" r:id="rId8"/>
     <p:sldId id="263" r:id="rId9"/>
-    <p:sldId id="259" r:id="rId10"/>
+    <p:sldId id="266" r:id="rId10"/>
+    <p:sldId id="259" r:id="rId11"/>
   </p:sldIdLst>
   <p:sldSz cx="12192000" cy="6858000"/>
   <p:notesSz cx="6858000" cy="9144000"/>
@@ -113,14 +114,6 @@
     </a:lvl9pPr>
   </p:defaultTextStyle>
 </p:presentation>
-</file>
-
-<file path=ppt/revisionInfo.xml><?xml version="1.0" encoding="utf-8"?>
-<p1510:revInfo xmlns:a="http://schemas.openxmlformats.org/drawingml/2006/main" xmlns:r="http://schemas.openxmlformats.org/officeDocument/2006/relationships" xmlns:p1510="http://schemas.microsoft.com/office/powerpoint/2015/10/main">
-  <p1510:revLst>
-    <p1510:client id="{44A48307-69DF-474C-8D55-EB11E5933EBC}" v="3" dt="2026-04-28T19:34:30.909"/>
-  </p1510:revLst>
-</p1510:revInfo>
 </file>
 
 <file path=ppt/slideLayouts/slideLayout1.xml><?xml version="1.0" encoding="utf-8"?>
@@ -3482,6 +3475,99 @@
 </p:sld>
 </file>
 
+<file path=ppt/slides/slide10.xml><?xml version="1.0" encoding="utf-8"?>
+<p:sld xmlns:a="http://schemas.openxmlformats.org/drawingml/2006/main" xmlns:r="http://schemas.openxmlformats.org/officeDocument/2006/relationships" xmlns:p="http://schemas.openxmlformats.org/presentationml/2006/main">
+  <p:cSld>
+    <p:spTree>
+      <p:nvGrpSpPr>
+        <p:cNvPr id="1" name=""/>
+        <p:cNvGrpSpPr/>
+        <p:nvPr/>
+      </p:nvGrpSpPr>
+      <p:grpSpPr>
+        <a:xfrm>
+          <a:off x="0" y="0"/>
+          <a:ext cx="0" cy="0"/>
+          <a:chOff x="0" y="0"/>
+          <a:chExt cx="0" cy="0"/>
+        </a:xfrm>
+      </p:grpSpPr>
+      <p:sp>
+        <p:nvSpPr>
+          <p:cNvPr id="2" name="Title 1">
+            <a:extLst>
+              <a:ext uri="{FF2B5EF4-FFF2-40B4-BE49-F238E27FC236}">
+                <a16:creationId xmlns:a16="http://schemas.microsoft.com/office/drawing/2014/main" id="{BF804E86-517F-3055-2987-652F5B082F89}"/>
+              </a:ext>
+            </a:extLst>
+          </p:cNvPr>
+          <p:cNvSpPr>
+            <a:spLocks noGrp="1"/>
+          </p:cNvSpPr>
+          <p:nvPr>
+            <p:ph type="title"/>
+          </p:nvPr>
+        </p:nvSpPr>
+        <p:spPr/>
+        <p:txBody>
+          <a:bodyPr/>
+          <a:lstStyle/>
+          <a:p>
+            <a:r>
+              <a:rPr lang="en-US" dirty="0"/>
+              <a:t>References</a:t>
+            </a:r>
+          </a:p>
+        </p:txBody>
+      </p:sp>
+      <p:sp>
+        <p:nvSpPr>
+          <p:cNvPr id="3" name="Content Placeholder 2">
+            <a:extLst>
+              <a:ext uri="{FF2B5EF4-FFF2-40B4-BE49-F238E27FC236}">
+                <a16:creationId xmlns:a16="http://schemas.microsoft.com/office/drawing/2014/main" id="{C6375CF7-B05D-702B-00CA-C38D5E83D80D}"/>
+              </a:ext>
+            </a:extLst>
+          </p:cNvPr>
+          <p:cNvSpPr>
+            <a:spLocks noGrp="1"/>
+          </p:cNvSpPr>
+          <p:nvPr>
+            <p:ph idx="1"/>
+          </p:nvPr>
+        </p:nvSpPr>
+        <p:spPr/>
+        <p:txBody>
+          <a:bodyPr/>
+          <a:lstStyle/>
+          <a:p>
+            <a:r>
+              <a:rPr lang="en-US" dirty="0"/>
+              <a:t>Data Set</a:t>
+            </a:r>
+          </a:p>
+          <a:p>
+            <a:pPr lvl="1"/>
+            <a:r>
+              <a:rPr lang="en-US" dirty="0"/>
+              <a:t>Yeh, I. (2009). Default of Credit Card Clients [Dataset]. UCI Machine Learning Repository. https://doi.org/10.24432/C55S3H.</a:t>
+            </a:r>
+          </a:p>
+        </p:txBody>
+      </p:sp>
+    </p:spTree>
+    <p:extLst>
+      <p:ext uri="{BB962C8B-B14F-4D97-AF65-F5344CB8AC3E}">
+        <p14:creationId xmlns:p14="http://schemas.microsoft.com/office/powerpoint/2010/main" val="53309062"/>
+      </p:ext>
+    </p:extLst>
+  </p:cSld>
+  <p:clrMapOvr>
+    <a:masterClrMapping/>
+  </p:clrMapOvr>
+</p:sld>
+</file>
+
 <file path=ppt/slides/slide2.xml><?xml version="1.0" encoding="utf-8"?>
 <p:sld xmlns:a="http://schemas.openxmlformats.org/drawingml/2006/main" xmlns:r="http://schemas.openxmlformats.org/officeDocument/2006/relationships" xmlns:p="http://schemas.openxmlformats.org/presentationml/2006/main">
   <p:cSld>
@@ -4847,7 +4933,7 @@
           <p:cNvPr id="2" name="Title 1">
             <a:extLst>
               <a:ext uri="{FF2B5EF4-FFF2-40B4-BE49-F238E27FC236}">
-                <a16:creationId xmlns:a16="http://schemas.microsoft.com/office/drawing/2014/main" id="{BF804E86-517F-3055-2987-652F5B082F89}"/>
+                <a16:creationId xmlns:a16="http://schemas.microsoft.com/office/drawing/2014/main" id="{A607AC8B-05EE-CD83-53A3-DB4E498B00B3}"/>
               </a:ext>
             </a:extLst>
           </p:cNvPr>
@@ -4858,27 +4944,64 @@
             <p:ph type="title"/>
           </p:nvPr>
         </p:nvSpPr>
-        <p:spPr/>
-        <p:txBody>
-          <a:bodyPr/>
-          <a:lstStyle/>
-          <a:p>
-            <a:r>
-              <a:rPr lang="en-US" dirty="0"/>
-              <a:t>References</a:t>
-            </a:r>
-          </a:p>
-        </p:txBody>
-      </p:sp>
-      <p:sp>
-        <p:nvSpPr>
-          <p:cNvPr id="3" name="Content Placeholder 2">
+        <p:spPr>
+          <a:xfrm>
+            <a:off x="1261872" y="365760"/>
+            <a:ext cx="9692640" cy="1325562"/>
+          </a:xfrm>
+        </p:spPr>
+        <p:txBody>
+          <a:bodyPr>
+            <a:normAutofit/>
+          </a:bodyPr>
+          <a:lstStyle/>
+          <a:p>
+            <a:r>
+              <a:rPr lang="en-US" dirty="0"/>
+              <a:t>Model Performance </a:t>
+            </a:r>
+          </a:p>
+        </p:txBody>
+      </p:sp>
+      <p:pic>
+        <p:nvPicPr>
+          <p:cNvPr id="5" name="Content Placeholder 4">
             <a:extLst>
               <a:ext uri="{FF2B5EF4-FFF2-40B4-BE49-F238E27FC236}">
-                <a16:creationId xmlns:a16="http://schemas.microsoft.com/office/drawing/2014/main" id="{C6375CF7-B05D-702B-00CA-C38D5E83D80D}"/>
+                <a16:creationId xmlns:a16="http://schemas.microsoft.com/office/drawing/2014/main" id="{B0DF529B-1D8F-B008-62B9-3B9686CE8577}"/>
               </a:ext>
             </a:extLst>
           </p:cNvPr>
+          <p:cNvPicPr>
+            <a:picLocks noChangeAspect="1"/>
+          </p:cNvPicPr>
+          <p:nvPr/>
+        </p:nvPicPr>
+        <p:blipFill>
+          <a:blip r:embed="rId2"/>
+          <a:stretch>
+            <a:fillRect/>
+          </a:stretch>
+        </p:blipFill>
+        <p:spPr>
+          <a:xfrm>
+            <a:off x="336109" y="3111795"/>
+            <a:ext cx="4448859" cy="1203876"/>
+          </a:xfrm>
+          <a:prstGeom prst="rect">
+            <a:avLst/>
+          </a:prstGeom>
+        </p:spPr>
+      </p:pic>
+      <p:sp>
+        <p:nvSpPr>
+          <p:cNvPr id="11" name="Content Placeholder 8">
+            <a:extLst>
+              <a:ext uri="{FF2B5EF4-FFF2-40B4-BE49-F238E27FC236}">
+                <a16:creationId xmlns:a16="http://schemas.microsoft.com/office/drawing/2014/main" id="{929B51B0-887C-6944-0865-77FC17033BD8}"/>
+              </a:ext>
+            </a:extLst>
+          </p:cNvPr>
           <p:cNvSpPr>
             <a:spLocks noGrp="1"/>
           </p:cNvSpPr>
@@ -4886,29 +5009,97 @@
             <p:ph idx="1"/>
           </p:nvPr>
         </p:nvSpPr>
-        <p:spPr/>
-        <p:txBody>
-          <a:bodyPr/>
-          <a:lstStyle/>
-          <a:p>
-            <a:r>
-              <a:rPr lang="en-US" dirty="0"/>
-              <a:t>Data Set</a:t>
+        <p:spPr>
+          <a:xfrm>
+            <a:off x="5078834" y="1933575"/>
+            <a:ext cx="5875678" cy="4246562"/>
+          </a:xfrm>
+        </p:spPr>
+        <p:txBody>
+          <a:bodyPr>
+            <a:normAutofit/>
+          </a:bodyPr>
+          <a:lstStyle/>
+          <a:p>
+            <a:r>
+              <a:rPr lang="en-US" dirty="0"/>
+              <a:t>We evaluated our data set over all 5 of the models and calculated the cross validation scores of 5 different values: Accuracy, Precision, Recall,  F1-Score, and ROC-AUC</a:t>
+            </a:r>
+          </a:p>
+          <a:p>
+            <a:r>
+              <a:rPr lang="en-US" dirty="0"/>
+              <a:t>We decided that Gradient Boosting gave us the best results, therefore that was our best model to use</a:t>
             </a:r>
           </a:p>
           <a:p>
             <a:pPr lvl="1"/>
             <a:r>
               <a:rPr lang="en-US" dirty="0"/>
-              <a:t>Yeh, I. (2009). Default of Credit Card Clients [Dataset]. UCI Machine Learning Repository. https://doi.org/10.24432/C55S3H.</a:t>
-            </a:r>
+              <a:t>Had the 1</a:t>
+            </a:r>
+            <a:r>
+              <a:rPr lang="en-US" baseline="30000" dirty="0"/>
+              <a:t>st</a:t>
+            </a:r>
+            <a:r>
+              <a:rPr lang="en-US" dirty="0"/>
+              <a:t>  accuracy, 2</a:t>
+            </a:r>
+            <a:r>
+              <a:rPr lang="en-US" baseline="30000" dirty="0"/>
+              <a:t>nd</a:t>
+            </a:r>
+            <a:r>
+              <a:rPr lang="en-US" dirty="0"/>
+              <a:t>  highest precision, 3</a:t>
+            </a:r>
+            <a:r>
+              <a:rPr lang="en-US" baseline="30000" dirty="0"/>
+              <a:t>rd</a:t>
+            </a:r>
+            <a:r>
+              <a:rPr lang="en-US" dirty="0"/>
+              <a:t> highest recall, 1</a:t>
+            </a:r>
+            <a:r>
+              <a:rPr lang="en-US" baseline="30000" dirty="0"/>
+              <a:t>st</a:t>
+            </a:r>
+            <a:r>
+              <a:rPr lang="en-US" dirty="0"/>
+              <a:t> highest F1-score, 1</a:t>
+            </a:r>
+            <a:r>
+              <a:rPr lang="en-US" baseline="30000" dirty="0"/>
+              <a:t>st</a:t>
+            </a:r>
+            <a:r>
+              <a:rPr lang="en-US" dirty="0"/>
+              <a:t> highest ROC-AUC </a:t>
+            </a:r>
+          </a:p>
+          <a:p>
+            <a:pPr lvl="1"/>
+            <a:r>
+              <a:rPr lang="en-US" dirty="0"/>
+              <a:t>To test our decision, we created a confusion matrix for the </a:t>
+            </a:r>
+            <a:r>
+              <a:rPr lang="en-US"/>
+              <a:t>Gradient Boosting model</a:t>
+            </a:r>
+          </a:p>
+          <a:p>
+            <a:pPr lvl="1"/>
+            <a:endParaRPr lang="en-US" dirty="0"/>
           </a:p>
         </p:txBody>
       </p:sp>
     </p:spTree>
     <p:extLst>
       <p:ext uri="{BB962C8B-B14F-4D97-AF65-F5344CB8AC3E}">
-        <p14:creationId xmlns:p14="http://schemas.microsoft.com/office/powerpoint/2010/main" val="53309062"/>
+        <p14:creationId xmlns:p14="http://schemas.microsoft.com/office/powerpoint/2010/main" val="3650884155"/>
       </p:ext>
     </p:extLst>
   </p:cSld>

</xml_diff>